<commit_message>
chapter 2-2 task ready, yay
</commit_message>
<xml_diff>
--- a/content/chapter2/images/k-fold.pptx
+++ b/content/chapter2/images/k-fold.pptx
@@ -260,7 +260,7 @@
           <a:p>
             <a:fld id="{6FAB6E6E-6763-3C4B-AB05-FF7A9C7B92DA}" type="datetimeFigureOut">
               <a:rPr lang="en-US" smtClean="0"/>
-              <a:t>5/20/26</a:t>
+              <a:t>5/22/26</a:t>
             </a:fld>
             <a:endParaRPr lang="en-US"/>
           </a:p>
@@ -458,7 +458,7 @@
           <a:p>
             <a:fld id="{6FAB6E6E-6763-3C4B-AB05-FF7A9C7B92DA}" type="datetimeFigureOut">
               <a:rPr lang="en-US" smtClean="0"/>
-              <a:t>5/20/26</a:t>
+              <a:t>5/22/26</a:t>
             </a:fld>
             <a:endParaRPr lang="en-US"/>
           </a:p>
@@ -666,7 +666,7 @@
           <a:p>
             <a:fld id="{6FAB6E6E-6763-3C4B-AB05-FF7A9C7B92DA}" type="datetimeFigureOut">
               <a:rPr lang="en-US" smtClean="0"/>
-              <a:t>5/20/26</a:t>
+              <a:t>5/22/26</a:t>
             </a:fld>
             <a:endParaRPr lang="en-US"/>
           </a:p>
@@ -864,7 +864,7 @@
           <a:p>
             <a:fld id="{6FAB6E6E-6763-3C4B-AB05-FF7A9C7B92DA}" type="datetimeFigureOut">
               <a:rPr lang="en-US" smtClean="0"/>
-              <a:t>5/20/26</a:t>
+              <a:t>5/22/26</a:t>
             </a:fld>
             <a:endParaRPr lang="en-US"/>
           </a:p>
@@ -1139,7 +1139,7 @@
           <a:p>
             <a:fld id="{6FAB6E6E-6763-3C4B-AB05-FF7A9C7B92DA}" type="datetimeFigureOut">
               <a:rPr lang="en-US" smtClean="0"/>
-              <a:t>5/20/26</a:t>
+              <a:t>5/22/26</a:t>
             </a:fld>
             <a:endParaRPr lang="en-US"/>
           </a:p>
@@ -1404,7 +1404,7 @@
           <a:p>
             <a:fld id="{6FAB6E6E-6763-3C4B-AB05-FF7A9C7B92DA}" type="datetimeFigureOut">
               <a:rPr lang="en-US" smtClean="0"/>
-              <a:t>5/20/26</a:t>
+              <a:t>5/22/26</a:t>
             </a:fld>
             <a:endParaRPr lang="en-US"/>
           </a:p>
@@ -1816,7 +1816,7 @@
           <a:p>
             <a:fld id="{6FAB6E6E-6763-3C4B-AB05-FF7A9C7B92DA}" type="datetimeFigureOut">
               <a:rPr lang="en-US" smtClean="0"/>
-              <a:t>5/20/26</a:t>
+              <a:t>5/22/26</a:t>
             </a:fld>
             <a:endParaRPr lang="en-US"/>
           </a:p>
@@ -1957,7 +1957,7 @@
           <a:p>
             <a:fld id="{6FAB6E6E-6763-3C4B-AB05-FF7A9C7B92DA}" type="datetimeFigureOut">
               <a:rPr lang="en-US" smtClean="0"/>
-              <a:t>5/20/26</a:t>
+              <a:t>5/22/26</a:t>
             </a:fld>
             <a:endParaRPr lang="en-US"/>
           </a:p>
@@ -2070,7 +2070,7 @@
           <a:p>
             <a:fld id="{6FAB6E6E-6763-3C4B-AB05-FF7A9C7B92DA}" type="datetimeFigureOut">
               <a:rPr lang="en-US" smtClean="0"/>
-              <a:t>5/20/26</a:t>
+              <a:t>5/22/26</a:t>
             </a:fld>
             <a:endParaRPr lang="en-US"/>
           </a:p>
@@ -2381,7 +2381,7 @@
           <a:p>
             <a:fld id="{6FAB6E6E-6763-3C4B-AB05-FF7A9C7B92DA}" type="datetimeFigureOut">
               <a:rPr lang="en-US" smtClean="0"/>
-              <a:t>5/20/26</a:t>
+              <a:t>5/22/26</a:t>
             </a:fld>
             <a:endParaRPr lang="en-US"/>
           </a:p>
@@ -2669,7 +2669,7 @@
           <a:p>
             <a:fld id="{6FAB6E6E-6763-3C4B-AB05-FF7A9C7B92DA}" type="datetimeFigureOut">
               <a:rPr lang="en-US" smtClean="0"/>
-              <a:t>5/20/26</a:t>
+              <a:t>5/22/26</a:t>
             </a:fld>
             <a:endParaRPr lang="en-US"/>
           </a:p>
@@ -2910,7 +2910,7 @@
           <a:p>
             <a:fld id="{6FAB6E6E-6763-3C4B-AB05-FF7A9C7B92DA}" type="datetimeFigureOut">
               <a:rPr lang="en-US" smtClean="0"/>
-              <a:t>5/20/26</a:t>
+              <a:t>5/22/26</a:t>
             </a:fld>
             <a:endParaRPr lang="en-US"/>
           </a:p>
@@ -3648,6 +3648,367 @@
               <a:rPr lang="en-US" dirty="0"/>
               <a:t>Performance estimation</a:t>
             </a:r>
+          </a:p>
+        </p:txBody>
+      </p:sp>
+      <p:sp>
+        <p:nvSpPr>
+          <p:cNvPr id="2" name="Cloud 1">
+            <a:extLst>
+              <a:ext uri="{FF2B5EF4-FFF2-40B4-BE49-F238E27FC236}">
+                <a16:creationId xmlns:a16="http://schemas.microsoft.com/office/drawing/2014/main" id="{8EB4D9BC-5FBA-3B1C-87B8-0B0578F11F07}"/>
+              </a:ext>
+            </a:extLst>
+          </p:cNvPr>
+          <p:cNvSpPr/>
+          <p:nvPr/>
+        </p:nvSpPr>
+        <p:spPr>
+          <a:xfrm>
+            <a:off x="297455" y="1704910"/>
+            <a:ext cx="3018622" cy="2809186"/>
+          </a:xfrm>
+          <a:prstGeom prst="cloud">
+            <a:avLst/>
+          </a:prstGeom>
+          <a:solidFill>
+            <a:schemeClr val="accent1">
+              <a:alpha val="41212"/>
+            </a:schemeClr>
+          </a:solidFill>
+        </p:spPr>
+        <p:style>
+          <a:lnRef idx="2">
+            <a:schemeClr val="accent1">
+              <a:shade val="15000"/>
+            </a:schemeClr>
+          </a:lnRef>
+          <a:fillRef idx="1">
+            <a:schemeClr val="accent1"/>
+          </a:fillRef>
+          <a:effectRef idx="0">
+            <a:schemeClr val="accent1"/>
+          </a:effectRef>
+          <a:fontRef idx="minor">
+            <a:schemeClr val="lt1"/>
+          </a:fontRef>
+        </p:style>
+        <p:txBody>
+          <a:bodyPr rtlCol="0" anchor="ctr"/>
+          <a:lstStyle/>
+          <a:p>
+            <a:pPr algn="ctr"/>
+            <a:r>
+              <a:rPr lang="en-US"/>
+              <a:t>´</a:t>
+            </a:r>
+            <a:endParaRPr lang="en-US" dirty="0"/>
+          </a:p>
+        </p:txBody>
+      </p:sp>
+      <p:sp>
+        <p:nvSpPr>
+          <p:cNvPr id="4" name="Cloud 3">
+            <a:extLst>
+              <a:ext uri="{FF2B5EF4-FFF2-40B4-BE49-F238E27FC236}">
+                <a16:creationId xmlns:a16="http://schemas.microsoft.com/office/drawing/2014/main" id="{D2BDEF43-571A-35F2-E943-5B46562ECDE4}"/>
+              </a:ext>
+            </a:extLst>
+          </p:cNvPr>
+          <p:cNvSpPr/>
+          <p:nvPr/>
+        </p:nvSpPr>
+        <p:spPr>
+          <a:xfrm>
+            <a:off x="5075107" y="1735491"/>
+            <a:ext cx="1860507" cy="1411082"/>
+          </a:xfrm>
+          <a:prstGeom prst="cloud">
+            <a:avLst/>
+          </a:prstGeom>
+          <a:solidFill>
+            <a:schemeClr val="accent1">
+              <a:alpha val="39074"/>
+            </a:schemeClr>
+          </a:solidFill>
+        </p:spPr>
+        <p:style>
+          <a:lnRef idx="2">
+            <a:schemeClr val="accent1">
+              <a:shade val="15000"/>
+            </a:schemeClr>
+          </a:lnRef>
+          <a:fillRef idx="1">
+            <a:schemeClr val="accent1"/>
+          </a:fillRef>
+          <a:effectRef idx="0">
+            <a:schemeClr val="accent1"/>
+          </a:effectRef>
+          <a:fontRef idx="minor">
+            <a:schemeClr val="lt1"/>
+          </a:fontRef>
+        </p:style>
+        <p:txBody>
+          <a:bodyPr rtlCol="0" anchor="ctr"/>
+          <a:lstStyle/>
+          <a:p>
+            <a:pPr algn="ctr"/>
+            <a:endParaRPr lang="en-US"/>
+          </a:p>
+        </p:txBody>
+      </p:sp>
+      <p:sp>
+        <p:nvSpPr>
+          <p:cNvPr id="9" name="Cloud 8">
+            <a:extLst>
+              <a:ext uri="{FF2B5EF4-FFF2-40B4-BE49-F238E27FC236}">
+                <a16:creationId xmlns:a16="http://schemas.microsoft.com/office/drawing/2014/main" id="{4A3790A9-8C39-A294-2A5F-2D54A304C70C}"/>
+              </a:ext>
+            </a:extLst>
+          </p:cNvPr>
+          <p:cNvSpPr/>
+          <p:nvPr/>
+        </p:nvSpPr>
+        <p:spPr>
+          <a:xfrm>
+            <a:off x="2882204" y="4315847"/>
+            <a:ext cx="2008419" cy="2095789"/>
+          </a:xfrm>
+          <a:prstGeom prst="cloud">
+            <a:avLst/>
+          </a:prstGeom>
+          <a:solidFill>
+            <a:schemeClr val="accent1">
+              <a:alpha val="39074"/>
+            </a:schemeClr>
+          </a:solidFill>
+        </p:spPr>
+        <p:style>
+          <a:lnRef idx="2">
+            <a:schemeClr val="accent1">
+              <a:shade val="15000"/>
+            </a:schemeClr>
+          </a:lnRef>
+          <a:fillRef idx="1">
+            <a:schemeClr val="accent1"/>
+          </a:fillRef>
+          <a:effectRef idx="0">
+            <a:schemeClr val="accent1"/>
+          </a:effectRef>
+          <a:fontRef idx="minor">
+            <a:schemeClr val="lt1"/>
+          </a:fontRef>
+        </p:style>
+        <p:txBody>
+          <a:bodyPr rtlCol="0" anchor="ctr"/>
+          <a:lstStyle/>
+          <a:p>
+            <a:pPr algn="ctr"/>
+            <a:endParaRPr lang="en-US"/>
+          </a:p>
+        </p:txBody>
+      </p:sp>
+      <p:sp>
+        <p:nvSpPr>
+          <p:cNvPr id="13" name="Cloud 12">
+            <a:extLst>
+              <a:ext uri="{FF2B5EF4-FFF2-40B4-BE49-F238E27FC236}">
+                <a16:creationId xmlns:a16="http://schemas.microsoft.com/office/drawing/2014/main" id="{7A8E0D8F-CFD1-B0A3-6589-6B7517436D9F}"/>
+              </a:ext>
+            </a:extLst>
+          </p:cNvPr>
+          <p:cNvSpPr/>
+          <p:nvPr/>
+        </p:nvSpPr>
+        <p:spPr>
+          <a:xfrm>
+            <a:off x="5835563" y="4133580"/>
+            <a:ext cx="2008419" cy="2095789"/>
+          </a:xfrm>
+          <a:prstGeom prst="cloud">
+            <a:avLst/>
+          </a:prstGeom>
+          <a:solidFill>
+            <a:schemeClr val="accent1">
+              <a:alpha val="39074"/>
+            </a:schemeClr>
+          </a:solidFill>
+        </p:spPr>
+        <p:style>
+          <a:lnRef idx="2">
+            <a:schemeClr val="accent1">
+              <a:shade val="15000"/>
+            </a:schemeClr>
+          </a:lnRef>
+          <a:fillRef idx="1">
+            <a:schemeClr val="accent1"/>
+          </a:fillRef>
+          <a:effectRef idx="0">
+            <a:schemeClr val="accent1"/>
+          </a:effectRef>
+          <a:fontRef idx="minor">
+            <a:schemeClr val="lt1"/>
+          </a:fontRef>
+        </p:style>
+        <p:txBody>
+          <a:bodyPr rtlCol="0" anchor="ctr"/>
+          <a:lstStyle/>
+          <a:p>
+            <a:pPr algn="ctr"/>
+            <a:endParaRPr lang="en-US"/>
+          </a:p>
+        </p:txBody>
+      </p:sp>
+      <p:sp>
+        <p:nvSpPr>
+          <p:cNvPr id="18" name="Cloud 17">
+            <a:extLst>
+              <a:ext uri="{FF2B5EF4-FFF2-40B4-BE49-F238E27FC236}">
+                <a16:creationId xmlns:a16="http://schemas.microsoft.com/office/drawing/2014/main" id="{BB6D7DDE-049C-6592-5B72-5B1EB4292EBB}"/>
+              </a:ext>
+            </a:extLst>
+          </p:cNvPr>
+          <p:cNvSpPr/>
+          <p:nvPr/>
+        </p:nvSpPr>
+        <p:spPr>
+          <a:xfrm rot="18269326">
+            <a:off x="8924855" y="4258732"/>
+            <a:ext cx="1650547" cy="1988117"/>
+          </a:xfrm>
+          <a:prstGeom prst="cloud">
+            <a:avLst/>
+          </a:prstGeom>
+          <a:solidFill>
+            <a:schemeClr val="accent1">
+              <a:alpha val="39074"/>
+            </a:schemeClr>
+          </a:solidFill>
+        </p:spPr>
+        <p:style>
+          <a:lnRef idx="2">
+            <a:schemeClr val="accent1">
+              <a:shade val="15000"/>
+            </a:schemeClr>
+          </a:lnRef>
+          <a:fillRef idx="1">
+            <a:schemeClr val="accent1"/>
+          </a:fillRef>
+          <a:effectRef idx="0">
+            <a:schemeClr val="accent1"/>
+          </a:effectRef>
+          <a:fontRef idx="minor">
+            <a:schemeClr val="lt1"/>
+          </a:fontRef>
+        </p:style>
+        <p:txBody>
+          <a:bodyPr rtlCol="0" anchor="ctr"/>
+          <a:lstStyle/>
+          <a:p>
+            <a:pPr algn="ctr"/>
+            <a:endParaRPr lang="en-US"/>
+          </a:p>
+        </p:txBody>
+      </p:sp>
+      <p:sp>
+        <p:nvSpPr>
+          <p:cNvPr id="19" name="Cloud 18">
+            <a:extLst>
+              <a:ext uri="{FF2B5EF4-FFF2-40B4-BE49-F238E27FC236}">
+                <a16:creationId xmlns:a16="http://schemas.microsoft.com/office/drawing/2014/main" id="{2EBFC7AF-E85F-D8E0-62DD-F476E5C65788}"/>
+              </a:ext>
+            </a:extLst>
+          </p:cNvPr>
+          <p:cNvSpPr/>
+          <p:nvPr/>
+        </p:nvSpPr>
+        <p:spPr>
+          <a:xfrm rot="18269326">
+            <a:off x="9117940" y="1540723"/>
+            <a:ext cx="2008419" cy="2095789"/>
+          </a:xfrm>
+          <a:prstGeom prst="cloud">
+            <a:avLst/>
+          </a:prstGeom>
+          <a:solidFill>
+            <a:schemeClr val="accent1">
+              <a:alpha val="39074"/>
+            </a:schemeClr>
+          </a:solidFill>
+        </p:spPr>
+        <p:style>
+          <a:lnRef idx="2">
+            <a:schemeClr val="accent1">
+              <a:shade val="15000"/>
+            </a:schemeClr>
+          </a:lnRef>
+          <a:fillRef idx="1">
+            <a:schemeClr val="accent1"/>
+          </a:fillRef>
+          <a:effectRef idx="0">
+            <a:schemeClr val="accent1"/>
+          </a:effectRef>
+          <a:fontRef idx="minor">
+            <a:schemeClr val="lt1"/>
+          </a:fontRef>
+        </p:style>
+        <p:txBody>
+          <a:bodyPr rtlCol="0" anchor="ctr"/>
+          <a:lstStyle/>
+          <a:p>
+            <a:pPr algn="ctr"/>
+            <a:endParaRPr lang="en-US"/>
+          </a:p>
+        </p:txBody>
+      </p:sp>
+      <p:sp>
+        <p:nvSpPr>
+          <p:cNvPr id="20" name="Cloud 19">
+            <a:extLst>
+              <a:ext uri="{FF2B5EF4-FFF2-40B4-BE49-F238E27FC236}">
+                <a16:creationId xmlns:a16="http://schemas.microsoft.com/office/drawing/2014/main" id="{E9151A74-8714-B25F-6204-2E5D1BD8E244}"/>
+              </a:ext>
+            </a:extLst>
+          </p:cNvPr>
+          <p:cNvSpPr/>
+          <p:nvPr/>
+        </p:nvSpPr>
+        <p:spPr>
+          <a:xfrm rot="18269326">
+            <a:off x="6462350" y="2577282"/>
+            <a:ext cx="1837278" cy="1818795"/>
+          </a:xfrm>
+          <a:prstGeom prst="cloud">
+            <a:avLst/>
+          </a:prstGeom>
+          <a:solidFill>
+            <a:schemeClr val="accent1">
+              <a:alpha val="39074"/>
+            </a:schemeClr>
+          </a:solidFill>
+        </p:spPr>
+        <p:style>
+          <a:lnRef idx="2">
+            <a:schemeClr val="accent1">
+              <a:shade val="15000"/>
+            </a:schemeClr>
+          </a:lnRef>
+          <a:fillRef idx="1">
+            <a:schemeClr val="accent1"/>
+          </a:fillRef>
+          <a:effectRef idx="0">
+            <a:schemeClr val="accent1"/>
+          </a:effectRef>
+          <a:fontRef idx="minor">
+            <a:schemeClr val="lt1"/>
+          </a:fontRef>
+        </p:style>
+        <p:txBody>
+          <a:bodyPr rtlCol="0" anchor="ctr"/>
+          <a:lstStyle/>
+          <a:p>
+            <a:pPr algn="ctr"/>
+            <a:endParaRPr lang="en-US"/>
           </a:p>
         </p:txBody>
       </p:sp>

</xml_diff>